<commit_message>
Deck: show the engine's real notice (how many abilities, never which)
Co-Authored-By: Claude Opus 5 (1M context) <noreply@anthropic.com>
</commit_message>
<xml_diff>
--- a/Mystique-apresentacao.pptx
+++ b/Mystique-apresentacao.pptx
@@ -3308,12 +3308,12 @@
         </p:nvSpPr>
         <p:spPr>
           <a:xfrm>
-            <a:off x="548640" y="4572000"/>
-            <a:ext cx="10881360" cy="1508760"/>
+            <a:off x="548640" y="4526280"/>
+            <a:ext cx="10881360" cy="1783080"/>
           </a:xfrm>
           <a:prstGeom prst="roundRect">
             <a:avLst>
-              <a:gd name="adj" fmla="val 6061"/>
+              <a:gd name="adj" fmla="val 5128"/>
             </a:avLst>
           </a:prstGeom>
           <a:solidFill>
@@ -3335,7 +3335,7 @@
         </p:nvSpPr>
         <p:spPr>
           <a:xfrm>
-            <a:off x="868680" y="4754880"/>
+            <a:off x="868680" y="4681728"/>
             <a:ext cx="10241280" cy="365760"/>
           </a:xfrm>
           <a:prstGeom prst="rect">
@@ -3360,7 +3360,7 @@
                 <a:ea typeface="Calibri" pitchFamily="34" charset="-122"/>
                 <a:cs typeface="Calibri" pitchFamily="34" charset="-120"/>
               </a:rPr>
-              <a:t>Tudo o que ela recebe depois que o agente responde:</a:t>
+              <a:t>O aviso que o motor anexa à resposta do agente, e é tudo o que ela recebe:</a:t>
             </a:r>
             <a:endParaRPr lang="en-US" sz="1400" dirty="0"/>
           </a:p>
@@ -3374,8 +3374,8 @@
         </p:nvSpPr>
         <p:spPr>
           <a:xfrm>
-            <a:off x="868680" y="5212080"/>
-            <a:ext cx="10241280" cy="594360"/>
+            <a:off x="868680" y="5074920"/>
+            <a:ext cx="10241280" cy="777240"/>
           </a:xfrm>
           <a:prstGeom prst="rect">
             <a:avLst/>
@@ -3391,7 +3391,7 @@
               <a:buNone/>
             </a:pPr>
             <a:r>
-              <a:rPr lang="en-US" sz="1900" dirty="0">
+              <a:rPr lang="en-US" sz="1600" dirty="0">
                 <a:solidFill>
                   <a:srgbClr val="FFFFFF"/>
                 </a:solidFill>
@@ -3405,7 +3405,7 @@
               <a:buNone/>
             </a:pPr>
             <a:r>
-              <a:rPr lang="en-US" sz="1900" b="1" dirty="0">
+              <a:rPr lang="en-US" sz="1600" b="1" dirty="0">
                 <a:solidFill>
                   <a:srgbClr val="F2C230"/>
                 </a:solidFill>
@@ -3413,13 +3413,13 @@
                 <a:ea typeface="Courier New" pitchFamily="34" charset="-122"/>
                 <a:cs typeface="Courier New" pitchFamily="34" charset="-120"/>
               </a:rPr>
-              <a:t>░░░░░░░░</a:t>
-            </a:r>
-            <a:pPr indent="0" marL="0">
-              <a:buNone/>
-            </a:pPr>
-            <a:r>
-              <a:rPr lang="en-US" sz="1900" dirty="0">
+              <a:t>1 habilidade especial</a:t>
+            </a:r>
+            <a:pPr indent="0" marL="0">
+              <a:buNone/>
+            </a:pPr>
+            <a:r>
+              <a:rPr lang="en-US" sz="1600" dirty="0">
                 <a:solidFill>
                   <a:srgbClr val="FFFFFF"/>
                 </a:solidFill>
@@ -3427,9 +3427,48 @@
                 <a:ea typeface="Courier New" pitchFamily="34" charset="-122"/>
                 <a:cs typeface="Courier New" pitchFamily="34" charset="-120"/>
               </a:rPr>
-              <a:t> para produzir essa resposta.</a:t>
-            </a:r>
-            <a:endParaRPr lang="en-US" sz="1900" dirty="0"/>
+              <a:t> para produzir essa resposta. Veja o que ela produziu.</a:t>
+            </a:r>
+            <a:endParaRPr lang="en-US" sz="1600" dirty="0"/>
+          </a:p>
+        </p:txBody>
+      </p:sp>
+      <p:sp>
+        <p:nvSpPr>
+          <p:cNvPr id="26" name="Text 24"/>
+          <p:cNvSpPr/>
+          <p:nvPr/>
+        </p:nvSpPr>
+        <p:spPr>
+          <a:xfrm>
+            <a:off x="868680" y="5852160"/>
+            <a:ext cx="10241280" cy="365760"/>
+          </a:xfrm>
+          <a:prstGeom prst="rect">
+            <a:avLst/>
+          </a:prstGeom>
+          <a:noFill/>
+          <a:ln/>
+        </p:spPr>
+        <p:txBody>
+          <a:bodyPr wrap="square" lIns="0" tIns="0" rIns="0" bIns="0" rtlCol="0" anchor="ctr"/>
+          <a:lstStyle/>
+          <a:p>
+            <a:pPr indent="0" marL="0">
+              <a:buNone/>
+            </a:pPr>
+            <a:r>
+              <a:rPr lang="en-US" sz="1400" i="1" dirty="0">
+                <a:solidFill>
+                  <a:srgbClr val="F2C230"/>
+                </a:solidFill>
+                <a:latin typeface="Calibri" pitchFamily="34" charset="0"/>
+                <a:ea typeface="Calibri" pitchFamily="34" charset="-122"/>
+                <a:cs typeface="Calibri" pitchFamily="34" charset="-120"/>
+              </a:rPr>
+              <a:t>Ela fica sabendo quantas habilidades o agente usou, nunca quais. O nome e o que ela faz, ela precisa deduzir.</a:t>
+            </a:r>
+            <a:endParaRPr lang="en-US" sz="1400" dirty="0"/>
           </a:p>
         </p:txBody>
       </p:sp>

</xml_diff>